<commit_message>
Implement HERO min minutes sensitivity analysis and related outputs
- Added scripts for generating HERO min minutes sensitivity analysis, including `hero_min_minutes_sensitivity_ladder.py`, which produces visualizations and meta data for varying minimum minutes thresholds (0, 10, 20).
- Introduced new CSV files containing binned draft rates and associated statistics for the years 2011-2021, enhancing the empirical analysis of player performance.
- Created new PNG visualizations to illustrate the sensitivity of draft rates to minimum minutes, aiding in the understanding of player selection dynamics.
- Updated README and slide documentation to include references to new outputs, ensuring clarity on the latest analysis tools and results.

These changes enhance the analytical capabilities of the project, providing deeper insights into the impact of minimum minutes on player draft rates.
</commit_message>
<xml_diff>
--- a/3-Master_Plan/re_entry/HEROs_and_PASSes/slides/auto/CHAR_PD17_HAND.pptx
+++ b/3-Master_Plan/re_entry/HEROs_and_PASSes/slides/auto/CHAR_PD17_HAND.pptx
@@ -5,7 +5,7 @@
     <p:sldMasterId id="2147483648" r:id="rId1"/>
   </p:sldMasterIdLst>
   <p:notesMasterIdLst>
-    <p:notesMasterId r:id="rId15"/>
+    <p:notesMasterId r:id="rId18"/>
   </p:notesMasterIdLst>
   <p:sldIdLst>
     <p:sldId id="265" r:id="rId2"/>
@@ -18,9 +18,12 @@
     <p:sldId id="286" r:id="rId9"/>
     <p:sldId id="289" r:id="rId10"/>
     <p:sldId id="290" r:id="rId11"/>
-    <p:sldId id="257" r:id="rId12"/>
-    <p:sldId id="275" r:id="rId13"/>
-    <p:sldId id="278" r:id="rId14"/>
+    <p:sldId id="293" r:id="rId12"/>
+    <p:sldId id="292" r:id="rId13"/>
+    <p:sldId id="294" r:id="rId14"/>
+    <p:sldId id="257" r:id="rId15"/>
+    <p:sldId id="275" r:id="rId16"/>
+    <p:sldId id="278" r:id="rId17"/>
   </p:sldIdLst>
   <p:sldSz cx="12192000" cy="6858000"/>
   <p:notesSz cx="6858000" cy="9144000"/>
@@ -559,7 +562,7 @@
           <a:p>
             <a:fld id="{0AA65AC5-4B69-CD42-A9CA-DA3CB3FA4FFA}" type="slidenum">
               <a:rPr lang="en-US" smtClean="0"/>
-              <a:t>12</a:t>
+              <a:t>15</a:t>
             </a:fld>
             <a:endParaRPr lang="en-US"/>
           </a:p>
@@ -7995,6 +7998,856 @@
           <a:chExt cx="0" cy="0"/>
         </a:xfrm>
       </p:grpSpPr>
+      <p:sp>
+        <p:nvSpPr>
+          <p:cNvPr id="2" name="TextBox 1"/>
+          <p:cNvSpPr txBox="1"/>
+          <p:nvPr/>
+        </p:nvSpPr>
+        <p:spPr>
+          <a:xfrm>
+            <a:off x="384048" y="219456"/>
+            <a:ext cx="11423599" cy="457200"/>
+          </a:xfrm>
+          <a:prstGeom prst="rect">
+            <a:avLst/>
+          </a:prstGeom>
+          <a:noFill/>
+        </p:spPr>
+        <p:txBody>
+          <a:bodyPr wrap="none">
+            <a:spAutoFit/>
+          </a:bodyPr>
+          <a:lstStyle/>
+          <a:p>
+            <a:r>
+              <a:rPr sz="2000" b="1" i="0" baseline="0">
+                <a:latin typeface="Calibri"/>
+              </a:rPr>
+              <a:t>NCAA roster sizes after the minutes filter</a:t>
+            </a:r>
+          </a:p>
+        </p:txBody>
+      </p:sp>
+      <p:sp>
+        <p:nvSpPr>
+          <p:cNvPr id="3" name="TextBox 2"/>
+          <p:cNvSpPr txBox="1"/>
+          <p:nvPr/>
+        </p:nvSpPr>
+        <p:spPr>
+          <a:xfrm>
+            <a:off x="384048" y="713232"/>
+            <a:ext cx="11423599" cy="246888"/>
+          </a:xfrm>
+          <a:prstGeom prst="rect">
+            <a:avLst/>
+          </a:prstGeom>
+          <a:noFill/>
+        </p:spPr>
+        <p:txBody>
+          <a:bodyPr wrap="none">
+            <a:spAutoFit/>
+          </a:bodyPr>
+          <a:lstStyle/>
+          <a:p>
+            <a:r>
+              <a:rPr sz="1000" b="0" i="0" baseline="0">
+                <a:latin typeface="Calibri"/>
+              </a:rPr>
+              <a:t>MBB 2011-2021 · min 20 min · mean=9.6 vs LG $C=15$</a:t>
+            </a:r>
+          </a:p>
+        </p:txBody>
+      </p:sp>
+      <p:pic>
+        <p:nvPicPr>
+          <p:cNvPr id="4" name="Picture 3" descr="GRANDCHILD_ncaa_roster_size_distribution_2011_2021.png"/>
+          <p:cNvPicPr>
+            <a:picLocks noChangeAspect="1"/>
+          </p:cNvPicPr>
+          <p:nvPr/>
+        </p:nvPicPr>
+        <p:blipFill>
+          <a:blip r:embed="rId2"/>
+          <a:stretch>
+            <a:fillRect/>
+          </a:stretch>
+        </p:blipFill>
+        <p:spPr>
+          <a:xfrm>
+            <a:off x="908273" y="916050"/>
+            <a:ext cx="10375454" cy="4063452"/>
+          </a:xfrm>
+          <a:prstGeom prst="rect">
+            <a:avLst/>
+          </a:prstGeom>
+        </p:spPr>
+      </p:pic>
+      <p:sp>
+        <p:nvSpPr>
+          <p:cNvPr id="5" name="TextBox 4"/>
+          <p:cNvSpPr txBox="1"/>
+          <p:nvPr/>
+        </p:nvSpPr>
+        <p:spPr>
+          <a:xfrm>
+            <a:off x="1089127" y="5405189"/>
+            <a:ext cx="11095528" cy="565952"/>
+          </a:xfrm>
+          <a:prstGeom prst="rect">
+            <a:avLst/>
+          </a:prstGeom>
+          <a:noFill/>
+        </p:spPr>
+        <p:txBody>
+          <a:bodyPr wrap="square" numCol="2">
+            <a:noAutofit/>
+          </a:bodyPr>
+          <a:lstStyle/>
+          <a:p>
+            <a:pPr>
+              <a:buChar char="•"/>
+            </a:pPr>
+            <a:r>
+              <a:rPr sz="1000" b="0" i="0" baseline="0" dirty="0">
+                <a:latin typeface="Calibri"/>
+              </a:rPr>
+              <a:t>  Qualifying players per real NCAA team-season (\</a:t>
+            </a:r>
+            <a:r>
+              <a:rPr sz="1000" b="0" i="0" baseline="0" dirty="0" err="1">
+                <a:latin typeface="Calibri"/>
+              </a:rPr>
+              <a:t>geq</a:t>
+            </a:r>
+            <a:r>
+              <a:rPr sz="1000" b="0" i="0" baseline="0" dirty="0">
+                <a:latin typeface="Calibri"/>
+              </a:rPr>
+              <a:t> 20 ESPN minutes).</a:t>
+            </a:r>
+          </a:p>
+          <a:p>
+            <a:pPr>
+              <a:buChar char="•"/>
+            </a:pPr>
+            <a:r>
+              <a:rPr sz="1000" b="0" i="0" baseline="0" dirty="0">
+                <a:latin typeface="Calibri"/>
+              </a:rPr>
+              <a:t>  $n=6,492$ team-seasons · mean=9.6 · median=11 · sd=3.6.</a:t>
+            </a:r>
+          </a:p>
+          <a:p>
+            <a:pPr>
+              <a:buChar char="•"/>
+            </a:pPr>
+            <a:r>
+              <a:rPr sz="1000" b="0" i="0" baseline="0" dirty="0">
+                <a:latin typeface="Calibri"/>
+              </a:rPr>
+              <a:t>  Red dotted = NCAA mean; orange dashed = LG fixed $C=15$.</a:t>
+            </a:r>
+          </a:p>
+          <a:p>
+            <a:pPr>
+              <a:buChar char="•"/>
+            </a:pPr>
+            <a:r>
+              <a:rPr sz="1000" b="0" i="0" baseline="0" dirty="0">
+                <a:latin typeface="Calibri"/>
+              </a:rPr>
+              <a:t>  Only 2.3\% of teams have exactly 15 qualifying players.</a:t>
+            </a:r>
+          </a:p>
+          <a:p>
+            <a:pPr>
+              <a:buChar char="•"/>
+            </a:pPr>
+            <a:r>
+              <a:rPr sz="1000" b="0" i="0" baseline="0" dirty="0">
+                <a:latin typeface="Calibri"/>
+              </a:rPr>
+              <a:t>  Same ability pool ~62k; LG repacks into J=N/15 synthetic 15-man leagues.</a:t>
+            </a:r>
+          </a:p>
+          <a:p>
+            <a:pPr>
+              <a:buChar char="•"/>
+            </a:pPr>
+            <a:r>
+              <a:rPr sz="1000" b="0" i="0" baseline="0" dirty="0">
+                <a:latin typeface="Calibri"/>
+              </a:rPr>
+              <a:t>  Minutes floor shapes peer count — state explicitly in methods.</a:t>
+            </a:r>
+          </a:p>
+        </p:txBody>
+      </p:sp>
+      <p:sp>
+        <p:nvSpPr>
+          <p:cNvPr id="6" name="TextBox 5"/>
+          <p:cNvSpPr txBox="1"/>
+          <p:nvPr/>
+        </p:nvSpPr>
+        <p:spPr>
+          <a:xfrm>
+            <a:off x="384048" y="6053328"/>
+            <a:ext cx="11423599" cy="420624"/>
+          </a:xfrm>
+          <a:prstGeom prst="rect">
+            <a:avLst/>
+          </a:prstGeom>
+          <a:noFill/>
+        </p:spPr>
+        <p:txBody>
+          <a:bodyPr wrap="square">
+            <a:spAutoFit/>
+          </a:bodyPr>
+          <a:lstStyle/>
+          <a:p>
+            <a:pPr algn="l"/>
+            <a:r>
+              <a:rPr sz="1100" b="1" i="0" baseline="0">
+                <a:latin typeface="Calibri"/>
+              </a:rPr>
+              <a:t>Talking point: empirical teams are ~10 rotation players; LG uses fixed 15 — comparability is distributional, not headcount.</a:t>
+            </a:r>
+          </a:p>
+        </p:txBody>
+      </p:sp>
+    </p:spTree>
+  </p:cSld>
+  <p:clrMapOvr>
+    <a:masterClrMapping/>
+  </p:clrMapOvr>
+</p:sld>
+</file>
+
+<file path=ppt/slides/slide12.xml><?xml version="1.0" encoding="utf-8"?>
+<p:sld xmlns:a="http://schemas.openxmlformats.org/drawingml/2006/main" xmlns:r="http://schemas.openxmlformats.org/officeDocument/2006/relationships" xmlns:p="http://schemas.openxmlformats.org/presentationml/2006/main">
+  <p:cSld>
+    <p:spTree>
+      <p:nvGrpSpPr>
+        <p:cNvPr id="1" name=""/>
+        <p:cNvGrpSpPr/>
+        <p:nvPr/>
+      </p:nvGrpSpPr>
+      <p:grpSpPr>
+        <a:xfrm>
+          <a:off x="0" y="0"/>
+          <a:ext cx="0" cy="0"/>
+          <a:chOff x="0" y="0"/>
+          <a:chExt cx="0" cy="0"/>
+        </a:xfrm>
+      </p:grpSpPr>
+      <p:sp>
+        <p:nvSpPr>
+          <p:cNvPr id="2" name="TextBox 1"/>
+          <p:cNvSpPr txBox="1"/>
+          <p:nvPr/>
+        </p:nvSpPr>
+        <p:spPr>
+          <a:xfrm>
+            <a:off x="384048" y="219456"/>
+            <a:ext cx="11423599" cy="457200"/>
+          </a:xfrm>
+          <a:prstGeom prst="rect">
+            <a:avLst/>
+          </a:prstGeom>
+          <a:noFill/>
+        </p:spPr>
+        <p:txBody>
+          <a:bodyPr wrap="none">
+            <a:spAutoFit/>
+          </a:bodyPr>
+          <a:lstStyle/>
+          <a:p>
+            <a:r>
+              <a:rPr sz="2000" b="1" i="0" baseline="0">
+                <a:latin typeface="Calibri"/>
+              </a:rPr>
+              <a:t>Hero sensitivity — min\_minutes ladder</a:t>
+            </a:r>
+          </a:p>
+        </p:txBody>
+      </p:sp>
+      <p:sp>
+        <p:nvSpPr>
+          <p:cNvPr id="3" name="TextBox 2"/>
+          <p:cNvSpPr txBox="1"/>
+          <p:nvPr/>
+        </p:nvSpPr>
+        <p:spPr>
+          <a:xfrm>
+            <a:off x="384048" y="713232"/>
+            <a:ext cx="11423599" cy="246888"/>
+          </a:xfrm>
+          <a:prstGeom prst="rect">
+            <a:avLst/>
+          </a:prstGeom>
+          <a:noFill/>
+        </p:spPr>
+        <p:txBody>
+          <a:bodyPr wrap="none">
+            <a:spAutoFit/>
+          </a:bodyPr>
+          <a:lstStyle/>
+          <a:p>
+            <a:r>
+              <a:rPr sz="1000" b="0" i="0" baseline="0">
+                <a:latin typeface="Calibri"/>
+              </a:rPr>
+              <a:t>MBB 2011-2021 · poolq\_loo ventiles · 0 / 10 / 20 min</a:t>
+            </a:r>
+          </a:p>
+        </p:txBody>
+      </p:sp>
+      <p:pic>
+        <p:nvPicPr>
+          <p:cNvPr id="4" name="Picture 3" descr="HERO_min_minutes_sensitivity_compare_2011_2021.png"/>
+          <p:cNvPicPr>
+            <a:picLocks noChangeAspect="1"/>
+          </p:cNvPicPr>
+          <p:nvPr/>
+        </p:nvPicPr>
+        <p:blipFill>
+          <a:blip r:embed="rId2"/>
+          <a:stretch>
+            <a:fillRect/>
+          </a:stretch>
+        </p:blipFill>
+        <p:spPr>
+          <a:xfrm>
+            <a:off x="468988" y="1220692"/>
+            <a:ext cx="11276037" cy="3219105"/>
+          </a:xfrm>
+          <a:prstGeom prst="rect">
+            <a:avLst/>
+          </a:prstGeom>
+        </p:spPr>
+      </p:pic>
+      <p:sp>
+        <p:nvSpPr>
+          <p:cNvPr id="5" name="TextBox 4"/>
+          <p:cNvSpPr txBox="1"/>
+          <p:nvPr/>
+        </p:nvSpPr>
+        <p:spPr>
+          <a:xfrm>
+            <a:off x="1305703" y="4827530"/>
+            <a:ext cx="10697609" cy="651613"/>
+          </a:xfrm>
+          <a:prstGeom prst="rect">
+            <a:avLst/>
+          </a:prstGeom>
+          <a:noFill/>
+        </p:spPr>
+        <p:txBody>
+          <a:bodyPr wrap="square" numCol="2">
+            <a:noAutofit/>
+          </a:bodyPr>
+          <a:lstStyle/>
+          <a:p>
+            <a:pPr>
+              <a:buChar char="•"/>
+            </a:pPr>
+            <a:r>
+              <a:rPr sz="1000" b="0" i="0" baseline="0" dirty="0">
+                <a:latin typeface="Calibri"/>
+              </a:rPr>
+              <a:t>  Hero x-axis: draft rate vs poolq_loo </a:t>
+            </a:r>
+            <a:r>
+              <a:rPr sz="1000" b="0" i="0" baseline="0" dirty="0" err="1">
+                <a:latin typeface="Calibri"/>
+              </a:rPr>
+              <a:t>ventiles</a:t>
+            </a:r>
+            <a:r>
+              <a:rPr sz="1000" b="0" i="0" baseline="0" dirty="0">
+                <a:latin typeface="Calibri"/>
+              </a:rPr>
+              <a:t> · MBB 2011-2021 · 16 quantile.</a:t>
+            </a:r>
+          </a:p>
+          <a:p>
+            <a:pPr>
+              <a:buChar char="•"/>
+            </a:pPr>
+            <a:r>
+              <a:rPr sz="1000" b="0" i="0" baseline="0" dirty="0">
+                <a:latin typeface="Calibri"/>
+              </a:rPr>
+              <a:t>  min\_minutes defines who enters the panel and LOO peer pool — not neutral QC.</a:t>
+            </a:r>
+          </a:p>
+          <a:p>
+            <a:pPr>
+              <a:buChar char="•"/>
+            </a:pPr>
+            <a:r>
+              <a:rPr sz="1000" b="0" i="0" baseline="0" dirty="0">
+                <a:latin typeface="Calibri"/>
+              </a:rPr>
+              <a:t>  min=0: $n=82,893$, drafted=1,136, bin16=1.39\%, </a:t>
+            </a:r>
+            <a:r>
+              <a:rPr sz="1000" b="0" i="0" baseline="0" dirty="0" err="1">
+                <a:latin typeface="Calibri"/>
+              </a:rPr>
+              <a:t>inverted_u_like</a:t>
+            </a:r>
+            <a:r>
+              <a:rPr sz="1000" b="0" i="0" baseline="0" dirty="0">
+                <a:latin typeface="Calibri"/>
+              </a:rPr>
+              <a:t>.</a:t>
+            </a:r>
+          </a:p>
+          <a:p>
+            <a:pPr>
+              <a:buChar char="•"/>
+            </a:pPr>
+            <a:r>
+              <a:rPr sz="1000" b="0" i="0" baseline="0" dirty="0">
+                <a:latin typeface="Calibri"/>
+              </a:rPr>
+              <a:t>  min=10: $n=72,687$, drafted=1,136, bin16=1.08\%, </a:t>
+            </a:r>
+            <a:r>
+              <a:rPr sz="1000" b="0" i="0" baseline="0" dirty="0" err="1">
+                <a:latin typeface="Calibri"/>
+              </a:rPr>
+              <a:t>inverted_u_like</a:t>
+            </a:r>
+            <a:r>
+              <a:rPr sz="1000" b="0" i="0" baseline="0" dirty="0">
+                <a:latin typeface="Calibri"/>
+              </a:rPr>
+              <a:t>.</a:t>
+            </a:r>
+          </a:p>
+          <a:p>
+            <a:pPr>
+              <a:buChar char="•"/>
+            </a:pPr>
+            <a:r>
+              <a:rPr sz="1000" b="0" i="0" baseline="0" dirty="0">
+                <a:latin typeface="Calibri"/>
+              </a:rPr>
+              <a:t>  min=20: $n=62,180$, drafted=1,134, bin16=1.16\%, </a:t>
+            </a:r>
+            <a:r>
+              <a:rPr sz="1000" b="0" i="0" baseline="0" dirty="0" err="1">
+                <a:latin typeface="Calibri"/>
+              </a:rPr>
+              <a:t>inverted_u_like</a:t>
+            </a:r>
+            <a:r>
+              <a:rPr sz="1000" b="0" i="0" baseline="0" dirty="0">
+                <a:latin typeface="Calibri"/>
+              </a:rPr>
+              <a:t>.</a:t>
+            </a:r>
+          </a:p>
+          <a:p>
+            <a:pPr>
+              <a:buChar char="•"/>
+            </a:pPr>
+            <a:r>
+              <a:rPr sz="1000" b="0" i="0" baseline="0" dirty="0">
+                <a:latin typeface="Calibri"/>
+              </a:rPr>
+              <a:t>  Hero lock: min=20 — cleanest top-</a:t>
+            </a:r>
+            <a:r>
+              <a:rPr sz="1000" b="0" i="0" baseline="0" dirty="0" err="1">
+                <a:latin typeface="Calibri"/>
+              </a:rPr>
+              <a:t>ventile</a:t>
+            </a:r>
+            <a:r>
+              <a:rPr sz="1000" b="0" i="0" baseline="0" dirty="0">
+                <a:latin typeface="Calibri"/>
+              </a:rPr>
+              <a:t> cliff; min=10 robust appendix.</a:t>
+            </a:r>
+          </a:p>
+          <a:p>
+            <a:pPr>
+              <a:buChar char="•"/>
+            </a:pPr>
+            <a:r>
+              <a:rPr sz="1000" b="0" i="0" baseline="0" dirty="0">
+                <a:latin typeface="Calibri"/>
+              </a:rPr>
+              <a:t>  We are not simulating minutes in LG.</a:t>
+            </a:r>
+          </a:p>
+        </p:txBody>
+      </p:sp>
+      <p:sp>
+        <p:nvSpPr>
+          <p:cNvPr id="6" name="TextBox 5"/>
+          <p:cNvSpPr txBox="1"/>
+          <p:nvPr/>
+        </p:nvSpPr>
+        <p:spPr>
+          <a:xfrm>
+            <a:off x="384048" y="6053328"/>
+            <a:ext cx="11423599" cy="420624"/>
+          </a:xfrm>
+          <a:prstGeom prst="rect">
+            <a:avLst/>
+          </a:prstGeom>
+          <a:noFill/>
+        </p:spPr>
+        <p:txBody>
+          <a:bodyPr wrap="square">
+            <a:spAutoFit/>
+          </a:bodyPr>
+          <a:lstStyle/>
+          <a:p>
+            <a:pPr algn="l"/>
+            <a:r>
+              <a:rPr sz="1100" b="1" i="0" baseline="0">
+                <a:latin typeface="Calibri"/>
+              </a:rPr>
+              <a:t>Talking point: inverted-U survives 10- and 20-minute floors; min=20 sharpens the elite ventile dip (+2 drafted vs min=0).</a:t>
+            </a:r>
+          </a:p>
+        </p:txBody>
+      </p:sp>
+    </p:spTree>
+  </p:cSld>
+  <p:clrMapOvr>
+    <a:masterClrMapping/>
+  </p:clrMapOvr>
+</p:sld>
+</file>
+
+<file path=ppt/slides/slide13.xml><?xml version="1.0" encoding="utf-8"?>
+<p:sld xmlns:a="http://schemas.openxmlformats.org/drawingml/2006/main" xmlns:r="http://schemas.openxmlformats.org/officeDocument/2006/relationships" xmlns:p="http://schemas.openxmlformats.org/presentationml/2006/main">
+  <p:cSld>
+    <p:spTree>
+      <p:nvGrpSpPr>
+        <p:cNvPr id="1" name=""/>
+        <p:cNvGrpSpPr/>
+        <p:nvPr/>
+      </p:nvGrpSpPr>
+      <p:grpSpPr>
+        <a:xfrm>
+          <a:off x="0" y="0"/>
+          <a:ext cx="0" cy="0"/>
+          <a:chOff x="0" y="0"/>
+          <a:chExt cx="0" cy="0"/>
+        </a:xfrm>
+      </p:grpSpPr>
+      <p:sp>
+        <p:nvSpPr>
+          <p:cNvPr id="2" name="TextBox 1"/>
+          <p:cNvSpPr txBox="1"/>
+          <p:nvPr/>
+        </p:nvSpPr>
+        <p:spPr>
+          <a:xfrm>
+            <a:off x="384048" y="219456"/>
+            <a:ext cx="11423599" cy="457200"/>
+          </a:xfrm>
+          <a:prstGeom prst="rect">
+            <a:avLst/>
+          </a:prstGeom>
+          <a:noFill/>
+        </p:spPr>
+        <p:txBody>
+          <a:bodyPr wrap="none">
+            <a:spAutoFit/>
+          </a:bodyPr>
+          <a:lstStyle/>
+          <a:p>
+            <a:r>
+              <a:rPr sz="2000" b="1" i="0" baseline="0">
+                <a:latin typeface="Calibri"/>
+              </a:rPr>
+              <a:t>Hero sensitivity — min\_minutes overlay</a:t>
+            </a:r>
+          </a:p>
+        </p:txBody>
+      </p:sp>
+      <p:sp>
+        <p:nvSpPr>
+          <p:cNvPr id="3" name="TextBox 2"/>
+          <p:cNvSpPr txBox="1"/>
+          <p:nvPr/>
+        </p:nvSpPr>
+        <p:spPr>
+          <a:xfrm>
+            <a:off x="384048" y="713232"/>
+            <a:ext cx="11423599" cy="246888"/>
+          </a:xfrm>
+          <a:prstGeom prst="rect">
+            <a:avLst/>
+          </a:prstGeom>
+          <a:noFill/>
+        </p:spPr>
+        <p:txBody>
+          <a:bodyPr wrap="none">
+            <a:spAutoFit/>
+          </a:bodyPr>
+          <a:lstStyle/>
+          <a:p>
+            <a:r>
+              <a:rPr sz="1000" b="0" i="0" baseline="0">
+                <a:latin typeface="Calibri"/>
+              </a:rPr>
+              <a:t>MBB 2011-2021 · same bins, three floors</a:t>
+            </a:r>
+          </a:p>
+        </p:txBody>
+      </p:sp>
+      <p:pic>
+        <p:nvPicPr>
+          <p:cNvPr id="4" name="Picture 3" descr="HERO_min_minutes_sensitivity_overlay_2011_2021.png"/>
+          <p:cNvPicPr>
+            <a:picLocks noChangeAspect="1"/>
+          </p:cNvPicPr>
+          <p:nvPr/>
+        </p:nvPicPr>
+        <p:blipFill>
+          <a:blip r:embed="rId2"/>
+          <a:stretch>
+            <a:fillRect/>
+          </a:stretch>
+        </p:blipFill>
+        <p:spPr>
+          <a:xfrm>
+            <a:off x="2020977" y="941832"/>
+            <a:ext cx="8150047" cy="4259516"/>
+          </a:xfrm>
+          <a:prstGeom prst="rect">
+            <a:avLst/>
+          </a:prstGeom>
+        </p:spPr>
+      </p:pic>
+      <p:sp>
+        <p:nvSpPr>
+          <p:cNvPr id="5" name="TextBox 4"/>
+          <p:cNvSpPr txBox="1"/>
+          <p:nvPr/>
+        </p:nvSpPr>
+        <p:spPr>
+          <a:xfrm>
+            <a:off x="784098" y="5205075"/>
+            <a:ext cx="11134852" cy="706776"/>
+          </a:xfrm>
+          <a:prstGeom prst="rect">
+            <a:avLst/>
+          </a:prstGeom>
+          <a:noFill/>
+        </p:spPr>
+        <p:txBody>
+          <a:bodyPr wrap="square" numCol="2">
+            <a:noAutofit/>
+          </a:bodyPr>
+          <a:lstStyle/>
+          <a:p>
+            <a:pPr>
+              <a:buChar char="•"/>
+            </a:pPr>
+            <a:r>
+              <a:rPr sz="1000" b="0" i="0" baseline="0" dirty="0">
+                <a:latin typeface="Calibri"/>
+              </a:rPr>
+              <a:t>  Hero x-axis: draft rate vs poolq_loo </a:t>
+            </a:r>
+            <a:r>
+              <a:rPr sz="1000" b="0" i="0" baseline="0" dirty="0" err="1">
+                <a:latin typeface="Calibri"/>
+              </a:rPr>
+              <a:t>ventiles</a:t>
+            </a:r>
+            <a:r>
+              <a:rPr sz="1000" b="0" i="0" baseline="0" dirty="0">
+                <a:latin typeface="Calibri"/>
+              </a:rPr>
+              <a:t> · MBB 2011-2021 · 16 quantile.</a:t>
+            </a:r>
+          </a:p>
+          <a:p>
+            <a:pPr>
+              <a:buChar char="•"/>
+            </a:pPr>
+            <a:r>
+              <a:rPr sz="1000" b="0" i="0" baseline="0" dirty="0">
+                <a:latin typeface="Calibri"/>
+              </a:rPr>
+              <a:t>  min\_minutes defines who enters the panel and LOO peer pool — not neutral QC.</a:t>
+            </a:r>
+          </a:p>
+          <a:p>
+            <a:pPr>
+              <a:buChar char="•"/>
+            </a:pPr>
+            <a:r>
+              <a:rPr sz="1000" b="0" i="0" baseline="0" dirty="0">
+                <a:latin typeface="Calibri"/>
+              </a:rPr>
+              <a:t>  min=0: $n=82,893$, drafted=1,136, bin16=1.39\%, </a:t>
+            </a:r>
+            <a:r>
+              <a:rPr sz="1000" b="0" i="0" baseline="0" dirty="0" err="1">
+                <a:latin typeface="Calibri"/>
+              </a:rPr>
+              <a:t>inverted_u_like</a:t>
+            </a:r>
+            <a:r>
+              <a:rPr sz="1000" b="0" i="0" baseline="0" dirty="0">
+                <a:latin typeface="Calibri"/>
+              </a:rPr>
+              <a:t>.</a:t>
+            </a:r>
+          </a:p>
+          <a:p>
+            <a:pPr>
+              <a:buChar char="•"/>
+            </a:pPr>
+            <a:r>
+              <a:rPr sz="1000" b="0" i="0" baseline="0" dirty="0">
+                <a:latin typeface="Calibri"/>
+              </a:rPr>
+              <a:t>  min=10: $n=72,687$, drafted=1,136, bin16=1.08\%, </a:t>
+            </a:r>
+            <a:r>
+              <a:rPr sz="1000" b="0" i="0" baseline="0" dirty="0" err="1">
+                <a:latin typeface="Calibri"/>
+              </a:rPr>
+              <a:t>inverted_u_like</a:t>
+            </a:r>
+            <a:r>
+              <a:rPr sz="1000" b="0" i="0" baseline="0" dirty="0">
+                <a:latin typeface="Calibri"/>
+              </a:rPr>
+              <a:t>.</a:t>
+            </a:r>
+          </a:p>
+          <a:p>
+            <a:pPr>
+              <a:buChar char="•"/>
+            </a:pPr>
+            <a:r>
+              <a:rPr sz="1000" b="0" i="0" baseline="0" dirty="0">
+                <a:latin typeface="Calibri"/>
+              </a:rPr>
+              <a:t>  min=20: $n=62,180$, drafted=1,134, bin16=1.16\%, </a:t>
+            </a:r>
+            <a:r>
+              <a:rPr sz="1000" b="0" i="0" baseline="0" dirty="0" err="1">
+                <a:latin typeface="Calibri"/>
+              </a:rPr>
+              <a:t>inverted_u_like</a:t>
+            </a:r>
+            <a:r>
+              <a:rPr sz="1000" b="0" i="0" baseline="0" dirty="0">
+                <a:latin typeface="Calibri"/>
+              </a:rPr>
+              <a:t>.</a:t>
+            </a:r>
+          </a:p>
+          <a:p>
+            <a:pPr>
+              <a:buChar char="•"/>
+            </a:pPr>
+            <a:r>
+              <a:rPr sz="1000" b="0" i="0" baseline="0" dirty="0">
+                <a:latin typeface="Calibri"/>
+              </a:rPr>
+              <a:t>  Overlay: same </a:t>
+            </a:r>
+            <a:r>
+              <a:rPr sz="1000" b="0" i="0" baseline="0" dirty="0" err="1">
+                <a:latin typeface="Calibri"/>
+              </a:rPr>
+              <a:t>estimand</a:t>
+            </a:r>
+            <a:r>
+              <a:rPr sz="1000" b="0" i="0" baseline="0" dirty="0">
+                <a:latin typeface="Calibri"/>
+              </a:rPr>
+              <a:t>, different playing-time floors.</a:t>
+            </a:r>
+          </a:p>
+          <a:p>
+            <a:pPr>
+              <a:buChar char="•"/>
+            </a:pPr>
+            <a:r>
+              <a:rPr sz="1000" b="0" i="0" baseline="0" dirty="0">
+                <a:latin typeface="Calibri"/>
+              </a:rPr>
+              <a:t>  We are not simulating minutes in LG.</a:t>
+            </a:r>
+          </a:p>
+        </p:txBody>
+      </p:sp>
+      <p:sp>
+        <p:nvSpPr>
+          <p:cNvPr id="6" name="TextBox 5"/>
+          <p:cNvSpPr txBox="1"/>
+          <p:nvPr/>
+        </p:nvSpPr>
+        <p:spPr>
+          <a:xfrm>
+            <a:off x="384048" y="6053328"/>
+            <a:ext cx="11423599" cy="420624"/>
+          </a:xfrm>
+          <a:prstGeom prst="rect">
+            <a:avLst/>
+          </a:prstGeom>
+          <a:noFill/>
+        </p:spPr>
+        <p:txBody>
+          <a:bodyPr wrap="square">
+            <a:spAutoFit/>
+          </a:bodyPr>
+          <a:lstStyle/>
+          <a:p>
+            <a:pPr algn="l"/>
+            <a:r>
+              <a:rPr sz="1100" b="1" i="0" baseline="0">
+                <a:latin typeface="Calibri"/>
+              </a:rPr>
+              <a:t>Talking point: pattern is not an artifact of one arbitrary cutoff.</a:t>
+            </a:r>
+          </a:p>
+        </p:txBody>
+      </p:sp>
+    </p:spTree>
+  </p:cSld>
+  <p:clrMapOvr>
+    <a:masterClrMapping/>
+  </p:clrMapOvr>
+</p:sld>
+</file>
+
+<file path=ppt/slides/slide14.xml><?xml version="1.0" encoding="utf-8"?>
+<p:sld xmlns:a="http://schemas.openxmlformats.org/drawingml/2006/main" xmlns:r="http://schemas.openxmlformats.org/officeDocument/2006/relationships" xmlns:p="http://schemas.openxmlformats.org/presentationml/2006/main">
+  <p:cSld>
+    <p:spTree>
+      <p:nvGrpSpPr>
+        <p:cNvPr id="1" name=""/>
+        <p:cNvGrpSpPr/>
+        <p:nvPr/>
+      </p:nvGrpSpPr>
+      <p:grpSpPr>
+        <a:xfrm>
+          <a:off x="0" y="0"/>
+          <a:ext cx="0" cy="0"/>
+          <a:chOff x="0" y="0"/>
+          <a:chExt cx="0" cy="0"/>
+        </a:xfrm>
+      </p:grpSpPr>
       <mc:AlternateContent xmlns:mc="http://schemas.openxmlformats.org/markup-compatibility/2006" xmlns:a14="http://schemas.microsoft.com/office/drawing/2010/main">
         <mc:Choice Requires="a14">
           <p:sp>
@@ -9160,7 +10013,7 @@
 </p:sld>
 </file>
 
-<file path=ppt/slides/slide12.xml><?xml version="1.0" encoding="utf-8"?>
+<file path=ppt/slides/slide15.xml><?xml version="1.0" encoding="utf-8"?>
 <p:sld xmlns:a="http://schemas.openxmlformats.org/drawingml/2006/main" xmlns:r="http://schemas.openxmlformats.org/officeDocument/2006/relationships" xmlns:p="http://schemas.openxmlformats.org/presentationml/2006/main">
   <p:cSld>
     <p:spTree>
@@ -10331,7 +11184,7 @@
 </p:sld>
 </file>
 
-<file path=ppt/slides/slide13.xml><?xml version="1.0" encoding="utf-8"?>
+<file path=ppt/slides/slide16.xml><?xml version="1.0" encoding="utf-8"?>
 <p:sld xmlns:a="http://schemas.openxmlformats.org/drawingml/2006/main" xmlns:r="http://schemas.openxmlformats.org/officeDocument/2006/relationships" xmlns:p="http://schemas.openxmlformats.org/presentationml/2006/main">
   <p:cSld>
     <p:spTree>

</xml_diff>